<commit_message>
Fill photo windows edge to edge instead of fading sample photos
The sample photos are small crops, and fading them into a flat dark
backdrop left muddy dark halos inside every frame. place() now scales
each photo to cover its window and crops, so there are no faded edges.
Drops the two crops too short to cover a window (IWC, Chopard) for two
that can, trims image-viewer arrows off the screenshot crops, redraws
the crop guide from the real window crop, and lightens the like-counter
shade in the grid mockups, which greyed the ivory covers.

Co-Authored-By: Claude Opus 5.5 <noreply@anthropic.com>
Claude-Session: https://claude.ai/code/session_018hJ1Rt5PKdhK6fMJUBjEvH
</commit_message>
<xml_diff>
--- a/douyin-cover/抖音封面模板.pptx
+++ b/douyin-cover/抖音封面模板.pptx
@@ -113,7 +113,7 @@
   <p:extLst>
     <p:ext uri="{521415D9-36F7-43E2-AB2F-B90AF26B5E84}">
       <p14:sectionLst xmlns:p14="http://schemas.microsoft.com/office/powerpoint/2010/main">
-        <p14:section name="使用说明" id="{1dd85d2c-24e8-272a-1e9f-9c1112494566}">
+        <p14:section name="使用说明" id="{f7b593f9-1ec1-c327-f260-6ee7b0ac8e66}">
           <p14:sldIdLst>
             <p14:sldId id="256"/>
             <p14:sldId id="257"/>
@@ -121,7 +121,7 @@
             <p14:sldId id="259"/>
           </p14:sldIdLst>
         </p14:section>
-        <p14:section name="封面模板" id="{2c1011c7-2198-4fe3-068f-a36edb0460bb}">
+        <p14:section name="封面模板" id="{c6f666d5-c5b9-59bd-d346-9932ec1b8853}">
           <p14:sldIdLst>
             <p14:sldId id="260"/>
             <p14:sldId id="261"/>

</xml_diff>